<commit_message>
Revise all course materials for AI-aligned RPS 2026
</commit_message>
<xml_diff>
--- a/@Materi Kuliah/Materi_ADW_Tingkat_Lanjut/Presentasi_ADW_Tingkat_Lanjut_Profesional_dari_HTML.pptx
+++ b/@Materi Kuliah/Materi_ADW_Tingkat_Lanjut/Presentasi_ADW_Tingkat_Lanjut_Profesional_dari_HTML.pptx
@@ -2,131 +2,36 @@
 <file path=ppt/presentation.xml><?xml version="1.0" encoding="utf-8"?>
 <p:presentation xmlns:p="http://schemas.openxmlformats.org/presentationml/2006/main">
   <p:sldMasterIdLst>
-    <p:sldMasterId xmlns:r="http://schemas.openxmlformats.org/officeDocument/2006/relationships" id="2147483648" r:id="R511a5443a7b24f80"/>
+    <p:sldMasterId xmlns:r="http://schemas.openxmlformats.org/officeDocument/2006/relationships" id="2147483648" r:id="R102ee33886eb49f2"/>
   </p:sldMasterIdLst>
   <p:notesMasterIdLst>
-    <p:notesMasterId xmlns:r="http://schemas.openxmlformats.org/officeDocument/2006/relationships" r:id="R346b9b6eb79d4613"/>
+    <p:notesMasterId xmlns:r="http://schemas.openxmlformats.org/officeDocument/2006/relationships" r:id="Rc0501a06a5bc4aa5"/>
   </p:notesMasterIdLst>
   <p:sldIdLst>
-    <p:sldId xmlns:r="http://schemas.openxmlformats.org/officeDocument/2006/relationships" id="256" r:id="R4989c1cf9d9e4c3e"/>
-    <p:sldId xmlns:r="http://schemas.openxmlformats.org/officeDocument/2006/relationships" id="257" r:id="R8ef87c48eec84e39"/>
-    <p:sldId xmlns:r="http://schemas.openxmlformats.org/officeDocument/2006/relationships" id="258" r:id="Ra8b08ffcdad94ba8"/>
-    <p:sldId xmlns:r="http://schemas.openxmlformats.org/officeDocument/2006/relationships" id="259" r:id="Rea1a89ea34bb4dd6"/>
-    <p:sldId xmlns:r="http://schemas.openxmlformats.org/officeDocument/2006/relationships" id="260" r:id="R796faab81be048e1"/>
-    <p:sldId xmlns:r="http://schemas.openxmlformats.org/officeDocument/2006/relationships" id="261" r:id="R249bdf2f028c432d"/>
-    <p:sldId xmlns:r="http://schemas.openxmlformats.org/officeDocument/2006/relationships" id="262" r:id="Raace0149d4c247f1"/>
-    <p:sldId xmlns:r="http://schemas.openxmlformats.org/officeDocument/2006/relationships" id="263" r:id="R628dc2a332aa4f28"/>
-    <p:sldId xmlns:r="http://schemas.openxmlformats.org/officeDocument/2006/relationships" id="264" r:id="Rbda837dfbbf04f89"/>
-    <p:sldId xmlns:r="http://schemas.openxmlformats.org/officeDocument/2006/relationships" id="265" r:id="R6e8dca802dbb452c"/>
-    <p:sldId xmlns:r="http://schemas.openxmlformats.org/officeDocument/2006/relationships" id="266" r:id="R876d216f2d964496"/>
-    <p:sldId xmlns:r="http://schemas.openxmlformats.org/officeDocument/2006/relationships" id="267" r:id="R29d9dc53b4474b19"/>
-    <p:sldId xmlns:r="http://schemas.openxmlformats.org/officeDocument/2006/relationships" id="268" r:id="Rf11ab8cfe42c44da"/>
-    <p:sldId xmlns:r="http://schemas.openxmlformats.org/officeDocument/2006/relationships" id="269" r:id="R47805a23a54e4ec5"/>
-    <p:sldId xmlns:r="http://schemas.openxmlformats.org/officeDocument/2006/relationships" id="270" r:id="R0a36174b42464c6d"/>
-    <p:sldId xmlns:r="http://schemas.openxmlformats.org/officeDocument/2006/relationships" id="271" r:id="R9464ba7496fd457b"/>
-    <p:sldId xmlns:r="http://schemas.openxmlformats.org/officeDocument/2006/relationships" id="272" r:id="R57b25115ca6243ad"/>
-    <p:sldId xmlns:r="http://schemas.openxmlformats.org/officeDocument/2006/relationships" id="273" r:id="R4027bbe9a36d4198"/>
-    <p:sldId xmlns:r="http://schemas.openxmlformats.org/officeDocument/2006/relationships" id="274" r:id="Rc7efc229af214fb5"/>
-    <p:sldId xmlns:r="http://schemas.openxmlformats.org/officeDocument/2006/relationships" id="275" r:id="Redf1410de64c43fa"/>
-    <p:sldId xmlns:r="http://schemas.openxmlformats.org/officeDocument/2006/relationships" id="276" r:id="R1084858efa77465f"/>
+    <p:sldId xmlns:r="http://schemas.openxmlformats.org/officeDocument/2006/relationships" id="256" r:id="R1ed28ae5e6aa45ee"/>
+    <p:sldId xmlns:r="http://schemas.openxmlformats.org/officeDocument/2006/relationships" id="257" r:id="Ree135ea58b82435a"/>
+    <p:sldId xmlns:r="http://schemas.openxmlformats.org/officeDocument/2006/relationships" id="258" r:id="Rf539dccc246d40d3"/>
+    <p:sldId xmlns:r="http://schemas.openxmlformats.org/officeDocument/2006/relationships" id="259" r:id="R7a368ca65f534989"/>
+    <p:sldId xmlns:r="http://schemas.openxmlformats.org/officeDocument/2006/relationships" id="260" r:id="Rbc485bdc01144947"/>
+    <p:sldId xmlns:r="http://schemas.openxmlformats.org/officeDocument/2006/relationships" id="261" r:id="Raef4c6c1430e4026"/>
+    <p:sldId xmlns:r="http://schemas.openxmlformats.org/officeDocument/2006/relationships" id="262" r:id="R97c6747d8aff4c76"/>
+    <p:sldId xmlns:r="http://schemas.openxmlformats.org/officeDocument/2006/relationships" id="263" r:id="R447ae7328be449a6"/>
+    <p:sldId xmlns:r="http://schemas.openxmlformats.org/officeDocument/2006/relationships" id="264" r:id="Rf8fc4edb2c6a4a9c"/>
+    <p:sldId xmlns:r="http://schemas.openxmlformats.org/officeDocument/2006/relationships" id="265" r:id="R998fa2fd47ee470f"/>
+    <p:sldId xmlns:r="http://schemas.openxmlformats.org/officeDocument/2006/relationships" id="266" r:id="R25e51730396c4fa0"/>
+    <p:sldId xmlns:r="http://schemas.openxmlformats.org/officeDocument/2006/relationships" id="267" r:id="R7ccc8904873840d5"/>
+    <p:sldId xmlns:r="http://schemas.openxmlformats.org/officeDocument/2006/relationships" id="268" r:id="Rec99d4553a06454e"/>
+    <p:sldId xmlns:r="http://schemas.openxmlformats.org/officeDocument/2006/relationships" id="269" r:id="Recfef0f052c843be"/>
+    <p:sldId xmlns:r="http://schemas.openxmlformats.org/officeDocument/2006/relationships" id="270" r:id="R0f840c75a11a488b"/>
+    <p:sldId xmlns:r="http://schemas.openxmlformats.org/officeDocument/2006/relationships" id="271" r:id="Re664ec9c29bc4fa4"/>
+    <p:sldId xmlns:r="http://schemas.openxmlformats.org/officeDocument/2006/relationships" id="272" r:id="R3cccd0c9eff84bfa"/>
+    <p:sldId xmlns:r="http://schemas.openxmlformats.org/officeDocument/2006/relationships" id="273" r:id="R90b97b62e4b54f5f"/>
+    <p:sldId xmlns:r="http://schemas.openxmlformats.org/officeDocument/2006/relationships" id="274" r:id="R7d0591479c9b4f35"/>
+    <p:sldId xmlns:r="http://schemas.openxmlformats.org/officeDocument/2006/relationships" id="275" r:id="R685f074a819b443c"/>
+    <p:sldId xmlns:r="http://schemas.openxmlformats.org/officeDocument/2006/relationships" id="276" r:id="Rcfaecb59ecaa4583"/>
   </p:sldIdLst>
   <p:sldSz cx="12192000" cy="6858000"/>
   <p:notesSz cx="6858000" cy="9144000"/>
-  <p:defaultTextStyle>
-    <a:defPPr xmlns:a="http://schemas.openxmlformats.org/drawingml/2006/main">
-      <a:defRPr lang="en-US"/>
-    </a:defPPr>
-    <a:lvl1pPr xmlns:a="http://schemas.openxmlformats.org/drawingml/2006/main" marL="0" indent="0" algn="l" defTabSz="914400">
-      <a:defRPr sz="1800" kern="1200">
-        <a:solidFill>
-          <a:schemeClr val="tx1"/>
-        </a:solidFill>
-        <a:latin typeface="+mn-lt"/>
-        <a:ea typeface="+mn-ea"/>
-        <a:cs typeface="+mn-cs"/>
-      </a:defRPr>
-    </a:lvl1pPr>
-    <a:lvl2pPr xmlns:a="http://schemas.openxmlformats.org/drawingml/2006/main" marL="457200" indent="0" algn="l" defTabSz="914400">
-      <a:defRPr sz="1800" kern="1200">
-        <a:solidFill>
-          <a:schemeClr val="tx1"/>
-        </a:solidFill>
-        <a:latin typeface="+mn-lt"/>
-        <a:ea typeface="+mn-ea"/>
-        <a:cs typeface="+mn-cs"/>
-      </a:defRPr>
-    </a:lvl2pPr>
-    <a:lvl3pPr xmlns:a="http://schemas.openxmlformats.org/drawingml/2006/main" marL="914400" indent="0" algn="l" defTabSz="914400">
-      <a:defRPr sz="1800" kern="1200">
-        <a:solidFill>
-          <a:schemeClr val="tx1"/>
-        </a:solidFill>
-        <a:latin typeface="+mn-lt"/>
-        <a:ea typeface="+mn-ea"/>
-        <a:cs typeface="+mn-cs"/>
-      </a:defRPr>
-    </a:lvl3pPr>
-    <a:lvl4pPr xmlns:a="http://schemas.openxmlformats.org/drawingml/2006/main" marL="1371600" indent="0" algn="l" defTabSz="914400">
-      <a:defRPr sz="1800" kern="1200">
-        <a:solidFill>
-          <a:schemeClr val="tx1"/>
-        </a:solidFill>
-        <a:latin typeface="+mn-lt"/>
-        <a:ea typeface="+mn-ea"/>
-        <a:cs typeface="+mn-cs"/>
-      </a:defRPr>
-    </a:lvl4pPr>
-    <a:lvl5pPr xmlns:a="http://schemas.openxmlformats.org/drawingml/2006/main" marL="1828800" indent="0" algn="l" defTabSz="914400">
-      <a:defRPr sz="1800" kern="1200">
-        <a:solidFill>
-          <a:schemeClr val="tx1"/>
-        </a:solidFill>
-        <a:latin typeface="+mn-lt"/>
-        <a:ea typeface="+mn-ea"/>
-        <a:cs typeface="+mn-cs"/>
-      </a:defRPr>
-    </a:lvl5pPr>
-    <a:lvl6pPr xmlns:a="http://schemas.openxmlformats.org/drawingml/2006/main" marL="2286000" indent="0" algn="l" defTabSz="914400">
-      <a:defRPr sz="1800" kern="1200">
-        <a:solidFill>
-          <a:schemeClr val="tx1"/>
-        </a:solidFill>
-        <a:latin typeface="+mn-lt"/>
-        <a:ea typeface="+mn-ea"/>
-        <a:cs typeface="+mn-cs"/>
-      </a:defRPr>
-    </a:lvl6pPr>
-    <a:lvl7pPr xmlns:a="http://schemas.openxmlformats.org/drawingml/2006/main" marL="2743200" indent="0" algn="l" defTabSz="914400">
-      <a:defRPr sz="1800" kern="1200">
-        <a:solidFill>
-          <a:schemeClr val="tx1"/>
-        </a:solidFill>
-        <a:latin typeface="+mn-lt"/>
-        <a:ea typeface="+mn-ea"/>
-        <a:cs typeface="+mn-cs"/>
-      </a:defRPr>
-    </a:lvl7pPr>
-    <a:lvl8pPr xmlns:a="http://schemas.openxmlformats.org/drawingml/2006/main" marL="3200400" indent="0" algn="l" defTabSz="914400">
-      <a:defRPr sz="1800" kern="1200">
-        <a:solidFill>
-          <a:schemeClr val="tx1"/>
-        </a:solidFill>
-        <a:latin typeface="+mn-lt"/>
-        <a:ea typeface="+mn-ea"/>
-        <a:cs typeface="+mn-cs"/>
-      </a:defRPr>
-    </a:lvl8pPr>
-    <a:lvl9pPr xmlns:a="http://schemas.openxmlformats.org/drawingml/2006/main" marL="3657600" indent="0" algn="l" defTabSz="914400">
-      <a:defRPr sz="1800" kern="1200">
-        <a:solidFill>
-          <a:schemeClr val="tx1"/>
-        </a:solidFill>
-        <a:latin typeface="+mn-lt"/>
-        <a:ea typeface="+mn-ea"/>
-        <a:cs typeface="+mn-cs"/>
-      </a:defRPr>
-    </a:lvl9pPr>
-  </p:defaultTextStyle>
 </p:presentation>
 </file>
 
@@ -1453,7 +1358,26 @@
         <p:txBody>
           <a:bodyPr xmlns:a="http://schemas.openxmlformats.org/drawingml/2006/main"/>
           <a:lstStyle xmlns:a="http://schemas.openxmlformats.org/drawingml/2006/main"/>
-          <a:p xmlns:a="http://schemas.openxmlformats.org/drawingml/2006/main"/>
+          <a:p xmlns:a="http://schemas.openxmlformats.org/drawingml/2006/main">
+            <a:r>
+              <a:t>[Sources]</a:t>
+            </a:r>
+          </a:p>
+          <a:p xmlns:a="http://schemas.openxmlformats.org/drawingml/2006/main">
+            <a:r>
+              <a:t>- RPS mata kuliah Revisi AI 2026, Program Studi S2 Statistika Terapan FMIPA Universitas Padjadjaran.</a:t>
+            </a:r>
+          </a:p>
+          <a:p xmlns:a="http://schemas.openxmlformats.org/drawingml/2006/main">
+            <a:r>
+              <a:t>[/Sources]</a:t>
+            </a:r>
+          </a:p>
+          <a:p xmlns:a="http://schemas.openxmlformats.org/drawingml/2006/main">
+            <a:r>
+              <a:t>Penutup: CPL tetap. AI adalah akselerator ketercapaian CPMK/Sub-CPMK, bukan pengganti penalaran statistika. Tekankan kewajiban prompt log ringkas, sumber, kode/notebook reproducible, validasi, dan audit trail.</a:t>
+            </a:r>
+          </a:p>
         </p:txBody>
       </p:sp>
       <p:sp>
@@ -2010,8 +1934,8 @@
   </p:cSld>
   <p:clrMap bg1="lt1" tx1="dk1" bg2="lt2" tx2="dk2" accent1="accent1" accent2="accent2" accent3="accent3" accent4="accent4" accent5="accent5" accent6="accent6" hlink="hlink" folHlink="folHlink"/>
   <p:sldLayoutIdLst>
-    <p:sldLayoutId xmlns:r="http://schemas.openxmlformats.org/officeDocument/2006/relationships" id="2147483649" r:id="Rc60ba9fe83d24abb"/>
-    <p:sldLayoutId xmlns:r="http://schemas.openxmlformats.org/officeDocument/2006/relationships" id="2147483650" r:id="Rce70ac7a341e4cec"/>
+    <p:sldLayoutId xmlns:r="http://schemas.openxmlformats.org/officeDocument/2006/relationships" id="2147483649" r:id="R85eed831c8024622"/>
+    <p:sldLayoutId xmlns:r="http://schemas.openxmlformats.org/officeDocument/2006/relationships" id="2147483650" r:id="Rda8816f6aa3e488c"/>
   </p:sldLayoutIdLst>
   <p:hf sldNum="0" hdr="0" ftr="0" dt="0"/>
   <p:txStyles>
@@ -2577,7 +2501,7 @@
           <p:nvPr/>
         </p:nvPicPr>
         <p:blipFill>
-          <a:blip xmlns:r="http://schemas.openxmlformats.org/officeDocument/2006/relationships" xmlns:a="http://schemas.openxmlformats.org/drawingml/2006/main" r:embed="R97666b554f0d46bb"/>
+          <a:blip xmlns:r="http://schemas.openxmlformats.org/officeDocument/2006/relationships" xmlns:a="http://schemas.openxmlformats.org/drawingml/2006/main" r:embed="R87dfebbfb47c44a4"/>
           <a:stretch xmlns:a="http://schemas.openxmlformats.org/drawingml/2006/main">
             <a:fillRect l="0" t="0" r="0" b="0"/>
           </a:stretch>
@@ -2723,7 +2647,7 @@
           <p:nvPr/>
         </p:nvPicPr>
         <p:blipFill>
-          <a:blip xmlns:r="http://schemas.openxmlformats.org/officeDocument/2006/relationships" xmlns:a="http://schemas.openxmlformats.org/drawingml/2006/main" r:embed="R9e5d8a223831469b"/>
+          <a:blip xmlns:r="http://schemas.openxmlformats.org/officeDocument/2006/relationships" xmlns:a="http://schemas.openxmlformats.org/drawingml/2006/main" r:embed="R2eeb8708fb264310"/>
           <a:stretch xmlns:a="http://schemas.openxmlformats.org/drawingml/2006/main">
             <a:fillRect l="0" t="0" r="0" b="0"/>
           </a:stretch>
@@ -3345,7 +3269,7 @@
           <p:nvPr/>
         </p:nvPicPr>
         <p:blipFill>
-          <a:blip xmlns:r="http://schemas.openxmlformats.org/officeDocument/2006/relationships" xmlns:a="http://schemas.openxmlformats.org/drawingml/2006/main" r:embed="R2ca7b09947304955"/>
+          <a:blip xmlns:r="http://schemas.openxmlformats.org/officeDocument/2006/relationships" xmlns:a="http://schemas.openxmlformats.org/drawingml/2006/main" r:embed="R3ec7b8e456044a35"/>
           <a:stretch xmlns:a="http://schemas.openxmlformats.org/drawingml/2006/main">
             <a:fillRect l="0" t="0" r="0" b="0"/>
           </a:stretch>
@@ -5495,7 +5419,7 @@
           <p:nvPr/>
         </p:nvPicPr>
         <p:blipFill>
-          <a:blip xmlns:r="http://schemas.openxmlformats.org/officeDocument/2006/relationships" xmlns:a="http://schemas.openxmlformats.org/drawingml/2006/main" r:embed="Rc0203660facb4887"/>
+          <a:blip xmlns:r="http://schemas.openxmlformats.org/officeDocument/2006/relationships" xmlns:a="http://schemas.openxmlformats.org/drawingml/2006/main" r:embed="R3772b1d588ea40d3"/>
           <a:stretch xmlns:a="http://schemas.openxmlformats.org/drawingml/2006/main">
             <a:fillRect l="0" t="0" r="0" b="0"/>
           </a:stretch>
@@ -5774,7 +5698,7 @@
           <p:nvPr/>
         </p:nvPicPr>
         <p:blipFill>
-          <a:blip xmlns:r="http://schemas.openxmlformats.org/officeDocument/2006/relationships" xmlns:a="http://schemas.openxmlformats.org/drawingml/2006/main" r:embed="R9423f9d254b640e0"/>
+          <a:blip xmlns:r="http://schemas.openxmlformats.org/officeDocument/2006/relationships" xmlns:a="http://schemas.openxmlformats.org/drawingml/2006/main" r:embed="R81f0cd9306bd4fce"/>
           <a:stretch xmlns:a="http://schemas.openxmlformats.org/drawingml/2006/main">
             <a:fillRect l="0" t="0" r="0" b="0"/>
           </a:stretch>
@@ -7308,7 +7232,7 @@
           <p:nvPr/>
         </p:nvPicPr>
         <p:blipFill>
-          <a:blip xmlns:r="http://schemas.openxmlformats.org/officeDocument/2006/relationships" xmlns:a="http://schemas.openxmlformats.org/drawingml/2006/main" r:embed="R1e20825391a74b97"/>
+          <a:blip xmlns:r="http://schemas.openxmlformats.org/officeDocument/2006/relationships" xmlns:a="http://schemas.openxmlformats.org/drawingml/2006/main" r:embed="Rd8061309e8594abf"/>
           <a:stretch xmlns:a="http://schemas.openxmlformats.org/drawingml/2006/main">
             <a:fillRect l="0" t="0" r="0" b="0"/>
           </a:stretch>
@@ -8477,7 +8401,7 @@
           <p:nvPr/>
         </p:nvPicPr>
         <p:blipFill>
-          <a:blip xmlns:r="http://schemas.openxmlformats.org/officeDocument/2006/relationships" xmlns:a="http://schemas.openxmlformats.org/drawingml/2006/main" r:embed="R03a9a953590148f2"/>
+          <a:blip xmlns:r="http://schemas.openxmlformats.org/officeDocument/2006/relationships" xmlns:a="http://schemas.openxmlformats.org/drawingml/2006/main" r:embed="Rb1b4e382fda54b17"/>
           <a:stretch xmlns:a="http://schemas.openxmlformats.org/drawingml/2006/main">
             <a:fillRect l="0" t="0" r="0" b="0"/>
           </a:stretch>
@@ -9704,7 +9628,7 @@
           <p:nvPr/>
         </p:nvPicPr>
         <p:blipFill>
-          <a:blip xmlns:r="http://schemas.openxmlformats.org/officeDocument/2006/relationships" xmlns:a="http://schemas.openxmlformats.org/drawingml/2006/main" r:embed="Rcaa121b792534513"/>
+          <a:blip xmlns:r="http://schemas.openxmlformats.org/officeDocument/2006/relationships" xmlns:a="http://schemas.openxmlformats.org/drawingml/2006/main" r:embed="R4f9f7924d1a0481e"/>
           <a:stretch xmlns:a="http://schemas.openxmlformats.org/drawingml/2006/main">
             <a:fillRect l="0" t="0" r="0" b="0"/>
           </a:stretch>
@@ -10909,7 +10833,7 @@
           <p:nvPr/>
         </p:nvPicPr>
         <p:blipFill>
-          <a:blip xmlns:r="http://schemas.openxmlformats.org/officeDocument/2006/relationships" xmlns:a="http://schemas.openxmlformats.org/drawingml/2006/main" r:embed="R29328bfc276f42ef"/>
+          <a:blip xmlns:r="http://schemas.openxmlformats.org/officeDocument/2006/relationships" xmlns:a="http://schemas.openxmlformats.org/drawingml/2006/main" r:embed="Rce70a15fca2c4a15"/>
           <a:stretch xmlns:a="http://schemas.openxmlformats.org/drawingml/2006/main">
             <a:fillRect l="0" t="0" r="0" b="0"/>
           </a:stretch>
@@ -11188,7 +11112,7 @@
           <p:nvPr/>
         </p:nvPicPr>
         <p:blipFill>
-          <a:blip xmlns:r="http://schemas.openxmlformats.org/officeDocument/2006/relationships" xmlns:a="http://schemas.openxmlformats.org/drawingml/2006/main" r:embed="Rdde8bc6370e24575"/>
+          <a:blip xmlns:r="http://schemas.openxmlformats.org/officeDocument/2006/relationships" xmlns:a="http://schemas.openxmlformats.org/drawingml/2006/main" r:embed="R2c70a02349dc4c42"/>
           <a:stretch xmlns:a="http://schemas.openxmlformats.org/drawingml/2006/main">
             <a:fillRect l="0" t="0" r="0" b="0"/>
           </a:stretch>
@@ -12733,7 +12657,7 @@
           <p:nvPr/>
         </p:nvPicPr>
         <p:blipFill>
-          <a:blip xmlns:r="http://schemas.openxmlformats.org/officeDocument/2006/relationships" xmlns:a="http://schemas.openxmlformats.org/drawingml/2006/main" r:embed="R31e14345c2cb4d9c"/>
+          <a:blip xmlns:r="http://schemas.openxmlformats.org/officeDocument/2006/relationships" xmlns:a="http://schemas.openxmlformats.org/drawingml/2006/main" r:embed="R8acf6c04efd44f5d"/>
           <a:stretch xmlns:a="http://schemas.openxmlformats.org/drawingml/2006/main">
             <a:fillRect l="0" t="0" r="0" b="0"/>
           </a:stretch>
@@ -14750,7 +14674,7 @@
           <p:nvPr/>
         </p:nvPicPr>
         <p:blipFill>
-          <a:blip xmlns:r="http://schemas.openxmlformats.org/officeDocument/2006/relationships" xmlns:a="http://schemas.openxmlformats.org/drawingml/2006/main" r:embed="Rfc558657255c46f3"/>
+          <a:blip xmlns:r="http://schemas.openxmlformats.org/officeDocument/2006/relationships" xmlns:a="http://schemas.openxmlformats.org/drawingml/2006/main" r:embed="R77e44f38d23f4de4"/>
           <a:stretch xmlns:a="http://schemas.openxmlformats.org/drawingml/2006/main">
             <a:fillRect l="0" t="0" r="0" b="0"/>
           </a:stretch>
@@ -15977,7 +15901,7 @@
           <p:nvPr/>
         </p:nvPicPr>
         <p:blipFill>
-          <a:blip xmlns:r="http://schemas.openxmlformats.org/officeDocument/2006/relationships" xmlns:a="http://schemas.openxmlformats.org/drawingml/2006/main" r:embed="R1244b29bccc942de"/>
+          <a:blip xmlns:r="http://schemas.openxmlformats.org/officeDocument/2006/relationships" xmlns:a="http://schemas.openxmlformats.org/drawingml/2006/main" r:embed="R788dec647685448e"/>
           <a:stretch xmlns:a="http://schemas.openxmlformats.org/drawingml/2006/main">
             <a:fillRect l="0" t="0" r="0" b="0"/>
           </a:stretch>
@@ -17118,7 +17042,7 @@
           <p:nvPr/>
         </p:nvPicPr>
         <p:blipFill>
-          <a:blip xmlns:r="http://schemas.openxmlformats.org/officeDocument/2006/relationships" xmlns:a="http://schemas.openxmlformats.org/drawingml/2006/main" r:embed="R9412c07b6fbb488c"/>
+          <a:blip xmlns:r="http://schemas.openxmlformats.org/officeDocument/2006/relationships" xmlns:a="http://schemas.openxmlformats.org/drawingml/2006/main" r:embed="Rb4c22f59e5ff4f4c"/>
           <a:stretch xmlns:a="http://schemas.openxmlformats.org/drawingml/2006/main">
             <a:fillRect l="0" t="0" r="0" b="0"/>
           </a:stretch>
@@ -18583,7 +18507,7 @@
           <p:nvPr/>
         </p:nvPicPr>
         <p:blipFill>
-          <a:blip xmlns:r="http://schemas.openxmlformats.org/officeDocument/2006/relationships" xmlns:a="http://schemas.openxmlformats.org/drawingml/2006/main" r:embed="Rf55adc2e170848f7"/>
+          <a:blip xmlns:r="http://schemas.openxmlformats.org/officeDocument/2006/relationships" xmlns:a="http://schemas.openxmlformats.org/drawingml/2006/main" r:embed="R6400bfa3bd854e1b"/>
           <a:stretch xmlns:a="http://schemas.openxmlformats.org/drawingml/2006/main">
             <a:fillRect l="0" t="0" r="0" b="0"/>
           </a:stretch>
@@ -18729,7 +18653,7 @@
           <p:nvPr/>
         </p:nvPicPr>
         <p:blipFill>
-          <a:blip xmlns:r="http://schemas.openxmlformats.org/officeDocument/2006/relationships" xmlns:a="http://schemas.openxmlformats.org/drawingml/2006/main" r:embed="Rf7731540061b4d06"/>
+          <a:blip xmlns:r="http://schemas.openxmlformats.org/officeDocument/2006/relationships" xmlns:a="http://schemas.openxmlformats.org/drawingml/2006/main" r:embed="R713115e7168a4ac1"/>
           <a:stretch xmlns:a="http://schemas.openxmlformats.org/drawingml/2006/main">
             <a:fillRect l="0" t="0" r="0" b="0"/>
           </a:stretch>
@@ -18833,7 +18757,7 @@
                 <a:ea typeface="Aptos Display"/>
                 <a:cs typeface="Aptos Display"/>
               </a:rPr>
-              <a:t>Dari data menuju</a:t>
+              <a:t>AI mempercepat proses,</a:t>
             </a:r>
           </a:p>
           <a:p xmlns:a="http://schemas.openxmlformats.org/drawingml/2006/main">
@@ -18849,7 +18773,7 @@
                 <a:ea typeface="Aptos Display"/>
                 <a:cs typeface="Aptos Display"/>
               </a:rPr>
-              <a:t>keputusan yang dapat diuji</a:t>
+              <a:t>penalaran tetap memimpin</a:t>
             </a:r>
           </a:p>
         </p:txBody>
@@ -18916,7 +18840,7 @@
         </p:spPr>
         <p:txBody>
           <a:bodyPr xmlns:a="http://schemas.openxmlformats.org/drawingml/2006/main" wrap="square" lIns="635" tIns="635" rIns="635" bIns="635" anchor="t">
-            <a:normAutofit fontScale="100000"/>
+            <a:normAutofit fontScale="93620"/>
           </a:bodyPr>
           <a:lstStyle xmlns:a="http://schemas.openxmlformats.org/drawingml/2006/main"/>
           <a:p xmlns:a="http://schemas.openxmlformats.org/drawingml/2006/main">
@@ -18932,7 +18856,7 @@
                 <a:ea typeface="Aptos"/>
                 <a:cs typeface="Aptos"/>
               </a:rPr>
-              <a:t>Analisis Deret Waktu Lanjut menghubungkan teori, data, metode, validasi, dan komunikasi untuk menghasilkan keputusan yang sahih, dapat direplikasi, dan bertanggung…</a:t>
+              <a:t>ADW Tingkat Lanjut memadukan teori, data, komputasi, validasi, dan komunikasi. AI mempercepat eksplorasi dan pemeriksaan awal; mahasiswa tetap memverifikasi asumsi, kode, hasil numerik, ketidakpastian, sumber, dan dampak sebelum mengambil keputusan.</a:t>
             </a:r>
           </a:p>
         </p:txBody>
@@ -19102,7 +19026,7 @@
           <p:nvPr/>
         </p:nvPicPr>
         <p:blipFill>
-          <a:blip xmlns:r="http://schemas.openxmlformats.org/officeDocument/2006/relationships" xmlns:a="http://schemas.openxmlformats.org/drawingml/2006/main" r:embed="R446d8d2f771848e1"/>
+          <a:blip xmlns:r="http://schemas.openxmlformats.org/officeDocument/2006/relationships" xmlns:a="http://schemas.openxmlformats.org/drawingml/2006/main" r:embed="Re34d82d62a614ea1"/>
           <a:stretch xmlns:a="http://schemas.openxmlformats.org/drawingml/2006/main">
             <a:fillRect l="0" t="0" r="0" b="0"/>
           </a:stretch>
@@ -20233,7 +20157,7 @@
           <p:nvPr/>
         </p:nvPicPr>
         <p:blipFill>
-          <a:blip xmlns:r="http://schemas.openxmlformats.org/officeDocument/2006/relationships" xmlns:a="http://schemas.openxmlformats.org/drawingml/2006/main" r:embed="Re3524a3c41fc4d59"/>
+          <a:blip xmlns:r="http://schemas.openxmlformats.org/officeDocument/2006/relationships" xmlns:a="http://schemas.openxmlformats.org/drawingml/2006/main" r:embed="R576a672ad4204f8a"/>
           <a:stretch xmlns:a="http://schemas.openxmlformats.org/drawingml/2006/main">
             <a:fillRect l="0" t="0" r="0" b="0"/>
           </a:stretch>
@@ -22337,7 +22261,7 @@
           <p:nvPr/>
         </p:nvPicPr>
         <p:blipFill>
-          <a:blip xmlns:r="http://schemas.openxmlformats.org/officeDocument/2006/relationships" xmlns:a="http://schemas.openxmlformats.org/drawingml/2006/main" r:embed="R09149a5c975e439b"/>
+          <a:blip xmlns:r="http://schemas.openxmlformats.org/officeDocument/2006/relationships" xmlns:a="http://schemas.openxmlformats.org/drawingml/2006/main" r:embed="R0fc170a922cc4528"/>
           <a:stretch xmlns:a="http://schemas.openxmlformats.org/drawingml/2006/main">
             <a:fillRect l="0" t="0" r="0" b="0"/>
           </a:stretch>
@@ -23619,7 +23543,7 @@
           <p:nvPr/>
         </p:nvPicPr>
         <p:blipFill>
-          <a:blip xmlns:r="http://schemas.openxmlformats.org/officeDocument/2006/relationships" xmlns:a="http://schemas.openxmlformats.org/drawingml/2006/main" r:embed="R2834ebd65cbe4350"/>
+          <a:blip xmlns:r="http://schemas.openxmlformats.org/officeDocument/2006/relationships" xmlns:a="http://schemas.openxmlformats.org/drawingml/2006/main" r:embed="R0dbf0c4bb1a943a5"/>
           <a:stretch xmlns:a="http://schemas.openxmlformats.org/drawingml/2006/main">
             <a:fillRect l="0" t="0" r="0" b="0"/>
           </a:stretch>
@@ -23898,7 +23822,7 @@
           <p:nvPr/>
         </p:nvPicPr>
         <p:blipFill>
-          <a:blip xmlns:r="http://schemas.openxmlformats.org/officeDocument/2006/relationships" xmlns:a="http://schemas.openxmlformats.org/drawingml/2006/main" r:embed="Rfd7a17d4f4ee435b"/>
+          <a:blip xmlns:r="http://schemas.openxmlformats.org/officeDocument/2006/relationships" xmlns:a="http://schemas.openxmlformats.org/drawingml/2006/main" r:embed="R76c0b805183f4c01"/>
           <a:stretch xmlns:a="http://schemas.openxmlformats.org/drawingml/2006/main">
             <a:fillRect l="0" t="0" r="0" b="0"/>
           </a:stretch>
@@ -25978,7 +25902,7 @@
           <p:nvPr/>
         </p:nvPicPr>
         <p:blipFill>
-          <a:blip xmlns:r="http://schemas.openxmlformats.org/officeDocument/2006/relationships" xmlns:a="http://schemas.openxmlformats.org/drawingml/2006/main" r:embed="R403f6a44627c4bce"/>
+          <a:blip xmlns:r="http://schemas.openxmlformats.org/officeDocument/2006/relationships" xmlns:a="http://schemas.openxmlformats.org/drawingml/2006/main" r:embed="Re94fdc6d10174065"/>
           <a:stretch xmlns:a="http://schemas.openxmlformats.org/drawingml/2006/main">
             <a:fillRect l="0" t="0" r="0" b="0"/>
           </a:stretch>
@@ -27391,7 +27315,7 @@
           <p:nvPr/>
         </p:nvPicPr>
         <p:blipFill>
-          <a:blip xmlns:r="http://schemas.openxmlformats.org/officeDocument/2006/relationships" xmlns:a="http://schemas.openxmlformats.org/drawingml/2006/main" r:embed="R50e78420a35f4072"/>
+          <a:blip xmlns:r="http://schemas.openxmlformats.org/officeDocument/2006/relationships" xmlns:a="http://schemas.openxmlformats.org/drawingml/2006/main" r:embed="R44bbc16a0f2048ef"/>
           <a:stretch xmlns:a="http://schemas.openxmlformats.org/drawingml/2006/main">
             <a:fillRect l="0" t="0" r="0" b="0"/>
           </a:stretch>

</xml_diff>